<commit_message>
Updated the PowerPoint presentation
</commit_message>
<xml_diff>
--- a/Introduction_to_Flask_EN.pptx
+++ b/Introduction_to_Flask_EN.pptx
@@ -854,7 +854,7 @@
         </p:nvSpPr>
         <p:spPr>
           <a:xfrm>
-            <a:off x="381300" y="685800"/>
+            <a:off x="381000" y="685800"/>
             <a:ext cx="6096000" cy="3429000"/>
           </a:xfrm>
           <a:custGeom>
@@ -989,7 +989,7 @@
         </p:nvSpPr>
         <p:spPr>
           <a:xfrm>
-            <a:off x="381300" y="685800"/>
+            <a:off x="381000" y="685800"/>
             <a:ext cx="6096000" cy="3429000"/>
           </a:xfrm>
           <a:custGeom>
@@ -1119,7 +1119,7 @@
         </p:nvSpPr>
         <p:spPr>
           <a:xfrm>
-            <a:off x="381300" y="685800"/>
+            <a:off x="381000" y="685800"/>
             <a:ext cx="6096000" cy="3429000"/>
           </a:xfrm>
           <a:custGeom>
@@ -2194,7 +2194,7 @@
         </p:nvSpPr>
         <p:spPr>
           <a:xfrm>
-            <a:off x="381300" y="685800"/>
+            <a:off x="381000" y="685800"/>
             <a:ext cx="6096000" cy="3429000"/>
           </a:xfrm>
           <a:custGeom>
@@ -3238,7 +3238,7 @@
         </p:nvSpPr>
         <p:spPr>
           <a:xfrm>
-            <a:off x="381300" y="685800"/>
+            <a:off x="381000" y="685800"/>
             <a:ext cx="6096000" cy="3429000"/>
           </a:xfrm>
           <a:custGeom>
@@ -3526,7 +3526,7 @@
         </p:nvSpPr>
         <p:spPr>
           <a:xfrm>
-            <a:off x="381300" y="685800"/>
+            <a:off x="381000" y="685800"/>
             <a:ext cx="6096000" cy="3429000"/>
           </a:xfrm>
           <a:custGeom>
@@ -3656,7 +3656,7 @@
         </p:nvSpPr>
         <p:spPr>
           <a:xfrm>
-            <a:off x="381300" y="685800"/>
+            <a:off x="381000" y="685800"/>
             <a:ext cx="6096000" cy="3429000"/>
           </a:xfrm>
           <a:custGeom>
@@ -3781,7 +3781,7 @@
         </p:nvSpPr>
         <p:spPr>
           <a:xfrm>
-            <a:off x="381300" y="685800"/>
+            <a:off x="381000" y="685800"/>
             <a:ext cx="6096000" cy="3429000"/>
           </a:xfrm>
           <a:custGeom>
@@ -20307,7 +20307,7 @@
               <a:buNone/>
             </a:pPr>
             <a:r>
-              <a:rPr lang="en" sz="4500">
+              <a:rPr lang="en" sz="4500" dirty="0">
                 <a:solidFill>
                   <a:srgbClr val="F1C232"/>
                 </a:solidFill>
@@ -20316,9 +20316,9 @@
                 <a:cs typeface="Calibri"/>
                 <a:sym typeface="Calibri"/>
               </a:rPr>
-              <a:t>Routing in flask</a:t>
-            </a:r>
-            <a:endParaRPr>
+              <a:t>Routing in Flask</a:t>
+            </a:r>
+            <a:endParaRPr dirty="0">
               <a:solidFill>
                 <a:srgbClr val="F1C232"/>
               </a:solidFill>
@@ -20817,7 +20817,7 @@
               <a:buNone/>
             </a:pPr>
             <a:r>
-              <a:rPr lang="en" sz="1050">
+              <a:rPr lang="en" sz="1050" dirty="0">
                 <a:solidFill>
                   <a:srgbClr val="6A9955"/>
                 </a:solidFill>
@@ -20831,7 +20831,7 @@
               </a:rPr>
               <a:t># Define the news route</a:t>
             </a:r>
-            <a:endParaRPr sz="1050">
+            <a:endParaRPr sz="1050" dirty="0">
               <a:solidFill>
                 <a:srgbClr val="6A9955"/>
               </a:solidFill>
@@ -20858,7 +20858,7 @@
               <a:buNone/>
             </a:pPr>
             <a:r>
-              <a:rPr lang="en" sz="1050">
+              <a:rPr lang="en" sz="1050" dirty="0">
                 <a:solidFill>
                   <a:srgbClr val="DCDCAA"/>
                 </a:solidFill>
@@ -20873,7 +20873,7 @@
               <a:t>@</a:t>
             </a:r>
             <a:r>
-              <a:rPr lang="en" sz="1050">
+              <a:rPr lang="en" sz="1050" dirty="0">
                 <a:solidFill>
                   <a:srgbClr val="9CDCFE"/>
                 </a:solidFill>
@@ -20888,7 +20888,7 @@
               <a:t>app</a:t>
             </a:r>
             <a:r>
-              <a:rPr lang="en" sz="1050">
+              <a:rPr lang="en" sz="1050" dirty="0">
                 <a:solidFill>
                   <a:srgbClr val="DCDCAA"/>
                 </a:solidFill>
@@ -20903,7 +20903,7 @@
               <a:t>.route</a:t>
             </a:r>
             <a:r>
-              <a:rPr lang="en" sz="1050">
+              <a:rPr lang="en" sz="1050" dirty="0">
                 <a:solidFill>
                   <a:srgbClr val="D4D4D4"/>
                 </a:solidFill>
@@ -20918,7 +20918,7 @@
               <a:t>(</a:t>
             </a:r>
             <a:r>
-              <a:rPr lang="en" sz="1050">
+              <a:rPr lang="en" sz="1050" dirty="0">
                 <a:solidFill>
                   <a:srgbClr val="CE9178"/>
                 </a:solidFill>
@@ -20933,7 +20933,7 @@
               <a:t>'/news/i/&lt;id&gt;'</a:t>
             </a:r>
             <a:r>
-              <a:rPr lang="en" sz="1050">
+              <a:rPr lang="en" sz="1050" dirty="0">
                 <a:solidFill>
                   <a:srgbClr val="D4D4D4"/>
                 </a:solidFill>
@@ -20947,7 +20947,7 @@
               </a:rPr>
               <a:t>)</a:t>
             </a:r>
-            <a:endParaRPr sz="1050">
+            <a:endParaRPr sz="1050" dirty="0">
               <a:solidFill>
                 <a:srgbClr val="D4D4D4"/>
               </a:solidFill>
@@ -20974,7 +20974,7 @@
               <a:buNone/>
             </a:pPr>
             <a:r>
-              <a:rPr lang="en" sz="1050">
+              <a:rPr lang="en" sz="1050" dirty="0">
                 <a:solidFill>
                   <a:srgbClr val="569CD6"/>
                 </a:solidFill>
@@ -20989,7 +20989,7 @@
               <a:t>def</a:t>
             </a:r>
             <a:r>
-              <a:rPr lang="en" sz="1050">
+              <a:rPr lang="en" sz="1050" dirty="0">
                 <a:solidFill>
                   <a:srgbClr val="D4D4D4"/>
                 </a:solidFill>
@@ -21004,7 +21004,7 @@
               <a:t> </a:t>
             </a:r>
             <a:r>
-              <a:rPr lang="en" sz="1050">
+              <a:rPr lang="en" sz="1050" dirty="0">
                 <a:solidFill>
                   <a:srgbClr val="DCDCAA"/>
                 </a:solidFill>
@@ -21019,7 +21019,7 @@
               <a:t>news</a:t>
             </a:r>
             <a:r>
-              <a:rPr lang="en" sz="1050">
+              <a:rPr lang="en" sz="1050" dirty="0">
                 <a:solidFill>
                   <a:srgbClr val="D4D4D4"/>
                 </a:solidFill>
@@ -21034,7 +21034,7 @@
               <a:t>(</a:t>
             </a:r>
             <a:r>
-              <a:rPr lang="en" sz="1050">
+              <a:rPr lang="en" sz="1050" dirty="0">
                 <a:solidFill>
                   <a:srgbClr val="9CDCFE"/>
                 </a:solidFill>
@@ -21049,7 +21049,7 @@
               <a:t>id</a:t>
             </a:r>
             <a:r>
-              <a:rPr lang="en" sz="1050">
+              <a:rPr lang="en" sz="1050" dirty="0">
                 <a:solidFill>
                   <a:srgbClr val="D4D4D4"/>
                 </a:solidFill>
@@ -21063,7 +21063,7 @@
               </a:rPr>
               <a:t>):</a:t>
             </a:r>
-            <a:endParaRPr sz="1050">
+            <a:endParaRPr sz="1050" dirty="0">
               <a:solidFill>
                 <a:srgbClr val="D4D4D4"/>
               </a:solidFill>
@@ -21090,7 +21090,7 @@
               <a:buNone/>
             </a:pPr>
             <a:r>
-              <a:rPr lang="en" sz="1050">
+              <a:rPr lang="en" sz="1050" dirty="0">
                 <a:solidFill>
                   <a:srgbClr val="D4D4D4"/>
                 </a:solidFill>
@@ -21105,7 +21105,7 @@
               <a:t>    </a:t>
             </a:r>
             <a:r>
-              <a:rPr lang="en" sz="1050">
+              <a:rPr lang="en" sz="1050" dirty="0">
                 <a:solidFill>
                   <a:srgbClr val="C586C0"/>
                 </a:solidFill>
@@ -21120,7 +21120,7 @@
               <a:t>return</a:t>
             </a:r>
             <a:r>
-              <a:rPr lang="en" sz="1050">
+              <a:rPr lang="en" sz="1050" dirty="0">
                 <a:solidFill>
                   <a:srgbClr val="D4D4D4"/>
                 </a:solidFill>
@@ -21135,7 +21135,7 @@
               <a:t> </a:t>
             </a:r>
             <a:r>
-              <a:rPr lang="en" sz="1050">
+              <a:rPr lang="en" sz="1050" dirty="0">
                 <a:solidFill>
                   <a:srgbClr val="DCDCAA"/>
                 </a:solidFill>
@@ -21150,7 +21150,7 @@
               <a:t>render_template</a:t>
             </a:r>
             <a:r>
-              <a:rPr lang="en" sz="1050">
+              <a:rPr lang="en" sz="1050" dirty="0">
                 <a:solidFill>
                   <a:srgbClr val="D4D4D4"/>
                 </a:solidFill>
@@ -21165,7 +21165,7 @@
               <a:t>(</a:t>
             </a:r>
             <a:r>
-              <a:rPr lang="en" sz="1050">
+              <a:rPr lang="en" sz="1050" dirty="0">
                 <a:solidFill>
                   <a:srgbClr val="CE9178"/>
                 </a:solidFill>
@@ -21180,7 +21180,7 @@
               <a:t>'news.html'</a:t>
             </a:r>
             <a:r>
-              <a:rPr lang="en" sz="1050">
+              <a:rPr lang="en" sz="1050" dirty="0">
                 <a:solidFill>
                   <a:srgbClr val="D4D4D4"/>
                 </a:solidFill>
@@ -21195,7 +21195,7 @@
               <a:t>, </a:t>
             </a:r>
             <a:r>
-              <a:rPr lang="en" sz="1050">
+              <a:rPr lang="en" sz="1050" dirty="0">
                 <a:solidFill>
                   <a:srgbClr val="9CDCFE"/>
                 </a:solidFill>
@@ -21210,7 +21210,7 @@
               <a:t>id</a:t>
             </a:r>
             <a:r>
-              <a:rPr lang="en" sz="1050">
+              <a:rPr lang="en" sz="1050" dirty="0">
                 <a:solidFill>
                   <a:srgbClr val="D4D4D4"/>
                 </a:solidFill>
@@ -21225,7 +21225,7 @@
               <a:t>=</a:t>
             </a:r>
             <a:r>
-              <a:rPr lang="en" sz="1050">
+              <a:rPr lang="en" sz="1050" dirty="0">
                 <a:solidFill>
                   <a:srgbClr val="9CDCFE"/>
                 </a:solidFill>
@@ -21240,7 +21240,7 @@
               <a:t>id</a:t>
             </a:r>
             <a:r>
-              <a:rPr lang="en" sz="1050">
+              <a:rPr lang="en" sz="1050" dirty="0">
                 <a:solidFill>
                   <a:srgbClr val="D4D4D4"/>
                 </a:solidFill>
@@ -21254,7 +21254,7 @@
               </a:rPr>
               <a:t>)</a:t>
             </a:r>
-            <a:endParaRPr sz="1050">
+            <a:endParaRPr sz="1050" dirty="0">
               <a:solidFill>
                 <a:srgbClr val="D4D4D4"/>
               </a:solidFill>
@@ -21816,7 +21816,7 @@
               <a:buNone/>
             </a:pPr>
             <a:r>
-              <a:rPr lang="en" sz="4500">
+              <a:rPr lang="en" sz="4500" dirty="0">
                 <a:solidFill>
                   <a:srgbClr val="F1C232"/>
                 </a:solidFill>
@@ -21825,9 +21825,9 @@
                 <a:cs typeface="Calibri"/>
                 <a:sym typeface="Calibri"/>
               </a:rPr>
-              <a:t>Routing in flask - request handling</a:t>
-            </a:r>
-            <a:endParaRPr>
+              <a:t>Routing in Flask - request handling</a:t>
+            </a:r>
+            <a:endParaRPr dirty="0">
               <a:solidFill>
                 <a:srgbClr val="F1C232"/>
               </a:solidFill>
@@ -23658,7 +23658,7 @@
               <a:buNone/>
             </a:pPr>
             <a:r>
-              <a:rPr lang="en" sz="4500">
+              <a:rPr lang="en" sz="4500" dirty="0">
                 <a:solidFill>
                   <a:srgbClr val="F1C232"/>
                 </a:solidFill>
@@ -23667,9 +23667,9 @@
                 <a:cs typeface="Calibri"/>
                 <a:sym typeface="Calibri"/>
               </a:rPr>
-              <a:t>File structure in a flask project</a:t>
-            </a:r>
-            <a:endParaRPr>
+              <a:t>File structure in a Flask project</a:t>
+            </a:r>
+            <a:endParaRPr dirty="0">
               <a:solidFill>
                 <a:srgbClr val="F1C232"/>
               </a:solidFill>
@@ -30011,7 +30011,7 @@
               <a:buChar char="-"/>
             </a:pPr>
             <a:r>
-              <a:rPr lang="en">
+              <a:rPr lang="en" dirty="0">
                 <a:solidFill>
                   <a:srgbClr val="F1C232"/>
                 </a:solidFill>
@@ -30022,7 +30022,7 @@
               </a:rPr>
               <a:t>P: Purpose</a:t>
             </a:r>
-            <a:endParaRPr>
+            <a:endParaRPr dirty="0">
               <a:solidFill>
                 <a:srgbClr val="F1C232"/>
               </a:solidFill>
@@ -30048,7 +30048,7 @@
               <a:buChar char="-"/>
             </a:pPr>
             <a:r>
-              <a:rPr lang="en">
+              <a:rPr lang="en" dirty="0">
                 <a:solidFill>
                   <a:srgbClr val="F1C232"/>
                 </a:solidFill>
@@ -30059,7 +30059,7 @@
               </a:rPr>
               <a:t>Give you a basic introduction to a central part of web development</a:t>
             </a:r>
-            <a:endParaRPr>
+            <a:endParaRPr dirty="0">
               <a:solidFill>
                 <a:srgbClr val="F1C232"/>
               </a:solidFill>
@@ -30085,7 +30085,7 @@
               <a:buChar char="-"/>
             </a:pPr>
             <a:r>
-              <a:rPr lang="en">
+              <a:rPr lang="en" dirty="0">
                 <a:solidFill>
                   <a:srgbClr val="F1C232"/>
                 </a:solidFill>
@@ -30096,7 +30096,7 @@
               </a:rPr>
               <a:t>Give you the chance to learn by doing it yourself</a:t>
             </a:r>
-            <a:endParaRPr>
+            <a:endParaRPr dirty="0">
               <a:solidFill>
                 <a:srgbClr val="F1C232"/>
               </a:solidFill>
@@ -30122,7 +30122,7 @@
               <a:buChar char="-"/>
             </a:pPr>
             <a:r>
-              <a:rPr lang="en">
+              <a:rPr lang="en" dirty="0">
                 <a:solidFill>
                   <a:srgbClr val="F1C232"/>
                 </a:solidFill>
@@ -30133,7 +30133,7 @@
               </a:rPr>
               <a:t>DR: Desired Result</a:t>
             </a:r>
-            <a:endParaRPr>
+            <a:endParaRPr dirty="0">
               <a:solidFill>
                 <a:srgbClr val="F1C232"/>
               </a:solidFill>
@@ -30159,7 +30159,7 @@
               <a:buChar char="-"/>
             </a:pPr>
             <a:r>
-              <a:rPr lang="en">
+              <a:rPr lang="en" dirty="0">
                 <a:solidFill>
                   <a:srgbClr val="F1C232"/>
                 </a:solidFill>
@@ -30168,9 +30168,9 @@
                 <a:cs typeface="Calibri"/>
                 <a:sym typeface="Calibri"/>
               </a:rPr>
-              <a:t>You should know the basic features of flask</a:t>
-            </a:r>
-            <a:endParaRPr>
+              <a:t>You should know the basic features of Flask</a:t>
+            </a:r>
+            <a:endParaRPr dirty="0">
               <a:solidFill>
                 <a:srgbClr val="F1C232"/>
               </a:solidFill>
@@ -30196,7 +30196,7 @@
               <a:buChar char="-"/>
             </a:pPr>
             <a:r>
-              <a:rPr lang="en">
+              <a:rPr lang="en" dirty="0">
                 <a:solidFill>
                   <a:srgbClr val="F1C232"/>
                 </a:solidFill>
@@ -30207,7 +30207,7 @@
               </a:rPr>
               <a:t>You should be able to create routes</a:t>
             </a:r>
-            <a:endParaRPr>
+            <a:endParaRPr dirty="0">
               <a:solidFill>
                 <a:srgbClr val="F1C232"/>
               </a:solidFill>
@@ -30233,7 +30233,7 @@
               <a:buChar char="-"/>
             </a:pPr>
             <a:r>
-              <a:rPr lang="en">
+              <a:rPr lang="en" dirty="0">
                 <a:solidFill>
                   <a:srgbClr val="F1C232"/>
                 </a:solidFill>
@@ -30244,7 +30244,7 @@
               </a:rPr>
               <a:t>You should be able to build simple html pages</a:t>
             </a:r>
-            <a:endParaRPr>
+            <a:endParaRPr dirty="0">
               <a:solidFill>
                 <a:srgbClr val="F1C232"/>
               </a:solidFill>
@@ -30270,7 +30270,7 @@
               <a:buChar char="-"/>
             </a:pPr>
             <a:r>
-              <a:rPr lang="en">
+              <a:rPr lang="en" dirty="0">
                 <a:solidFill>
                   <a:srgbClr val="F1C232"/>
                 </a:solidFill>
@@ -30281,7 +30281,7 @@
               </a:rPr>
               <a:t>A:Agenda</a:t>
             </a:r>
-            <a:endParaRPr>
+            <a:endParaRPr dirty="0">
               <a:solidFill>
                 <a:srgbClr val="F1C232"/>
               </a:solidFill>
@@ -30302,7 +30302,7 @@
               <a:buNone/>
             </a:pPr>
             <a:r>
-              <a:rPr lang="en">
+              <a:rPr lang="en" dirty="0">
                 <a:solidFill>
                   <a:srgbClr val="F1C232"/>
                 </a:solidFill>
@@ -30313,7 +30313,7 @@
               </a:rPr>
               <a:t>→</a:t>
             </a:r>
-            <a:endParaRPr>
+            <a:endParaRPr dirty="0">
               <a:solidFill>
                 <a:srgbClr val="F1C232"/>
               </a:solidFill>
@@ -30333,7 +30333,7 @@
               </a:spcAft>
               <a:buNone/>
             </a:pPr>
-            <a:endParaRPr>
+            <a:endParaRPr dirty="0">
               <a:solidFill>
                 <a:srgbClr val="F1C232"/>
               </a:solidFill>
@@ -30353,7 +30353,7 @@
               </a:spcAft>
               <a:buNone/>
             </a:pPr>
-            <a:endParaRPr>
+            <a:endParaRPr dirty="0">
               <a:solidFill>
                 <a:srgbClr val="F1C232"/>
               </a:solidFill>
@@ -30373,7 +30373,7 @@
               </a:spcAft>
               <a:buNone/>
             </a:pPr>
-            <a:endParaRPr>
+            <a:endParaRPr dirty="0">
               <a:solidFill>
                 <a:srgbClr val="F1C232"/>
               </a:solidFill>
@@ -30393,7 +30393,7 @@
               </a:spcAft>
               <a:buNone/>
             </a:pPr>
-            <a:endParaRPr>
+            <a:endParaRPr dirty="0">
               <a:solidFill>
                 <a:srgbClr val="F1C232"/>
               </a:solidFill>
@@ -31668,7 +31668,7 @@
           <p:nvPr>
             <p:extLst>
               <p:ext uri="{D42A27DB-BD31-4B8C-83A1-F6EECF244321}">
-                <p14:modId xmlns:p14="http://schemas.microsoft.com/office/powerpoint/2010/main" val="2302099371"/>
+                <p14:modId xmlns:p14="http://schemas.microsoft.com/office/powerpoint/2010/main" val="3084399580"/>
               </p:ext>
             </p:extLst>
           </p:nvPr>
@@ -31951,7 +31951,7 @@
                             <a:srgbClr val="F1C232"/>
                           </a:solidFill>
                         </a:rPr>
-                        <a:t>What flask is and why we use it</a:t>
+                        <a:t>What Flask is and why we use it</a:t>
                       </a:r>
                     </a:p>
                   </a:txBody>
@@ -33717,7 +33717,7 @@
               <a:buNone/>
             </a:pPr>
             <a:r>
-              <a:rPr lang="en" sz="4500">
+              <a:rPr lang="en" sz="4500" dirty="0">
                 <a:solidFill>
                   <a:srgbClr val="F1C232"/>
                 </a:solidFill>
@@ -33726,9 +33726,9 @@
                 <a:cs typeface="Calibri"/>
                 <a:sym typeface="Calibri"/>
               </a:rPr>
-              <a:t>What is flask?</a:t>
-            </a:r>
-            <a:endParaRPr>
+              <a:t>What is Flask?</a:t>
+            </a:r>
+            <a:endParaRPr dirty="0">
               <a:solidFill>
                 <a:srgbClr val="F1C232"/>
               </a:solidFill>
@@ -34360,7 +34360,7 @@
               <a:buNone/>
             </a:pPr>
             <a:r>
-              <a:rPr lang="en" sz="4500">
+              <a:rPr lang="en" sz="4500" dirty="0">
                 <a:solidFill>
                   <a:srgbClr val="F1C232"/>
                 </a:solidFill>
@@ -34369,9 +34369,9 @@
                 <a:cs typeface="Calibri"/>
                 <a:sym typeface="Calibri"/>
               </a:rPr>
-              <a:t>Why do we use flask?</a:t>
-            </a:r>
-            <a:endParaRPr>
+              <a:t>Why do we use Flask?</a:t>
+            </a:r>
+            <a:endParaRPr dirty="0">
               <a:solidFill>
                 <a:srgbClr val="F1C232"/>
               </a:solidFill>
@@ -35183,7 +35183,7 @@
               <a:buNone/>
             </a:pPr>
             <a:r>
-              <a:rPr lang="en" sz="4500">
+              <a:rPr lang="en" sz="4500" dirty="0">
                 <a:solidFill>
                   <a:srgbClr val="F1C232"/>
                 </a:solidFill>
@@ -35192,9 +35192,9 @@
                 <a:cs typeface="Calibri"/>
                 <a:sym typeface="Calibri"/>
               </a:rPr>
-              <a:t>Simple flask application</a:t>
-            </a:r>
-            <a:endParaRPr>
+              <a:t>Simple Flask application</a:t>
+            </a:r>
+            <a:endParaRPr dirty="0">
               <a:solidFill>
                 <a:srgbClr val="F1C232"/>
               </a:solidFill>
@@ -36733,7 +36733,7 @@
               <a:buNone/>
             </a:pPr>
             <a:r>
-              <a:rPr lang="en" sz="4500">
+              <a:rPr lang="en" sz="4500" dirty="0">
                 <a:solidFill>
                   <a:srgbClr val="F1C232"/>
                 </a:solidFill>
@@ -36742,9 +36742,9 @@
                 <a:cs typeface="Calibri"/>
                 <a:sym typeface="Calibri"/>
               </a:rPr>
-              <a:t>How to run/start a flask app</a:t>
-            </a:r>
-            <a:endParaRPr>
+              <a:t>How to run/start a Flask app</a:t>
+            </a:r>
+            <a:endParaRPr dirty="0">
               <a:solidFill>
                 <a:srgbClr val="F1C232"/>
               </a:solidFill>
@@ -37413,7 +37413,7 @@
               <a:buNone/>
             </a:pPr>
             <a:r>
-              <a:rPr lang="en" sz="4500">
+              <a:rPr lang="en" sz="4500" dirty="0">
                 <a:solidFill>
                   <a:srgbClr val="F1C232"/>
                 </a:solidFill>
@@ -37422,9 +37422,9 @@
                 <a:cs typeface="Calibri"/>
                 <a:sym typeface="Calibri"/>
               </a:rPr>
-              <a:t>Routing in flask</a:t>
-            </a:r>
-            <a:endParaRPr>
+              <a:t>Routing in Flask</a:t>
+            </a:r>
+            <a:endParaRPr dirty="0">
               <a:solidFill>
                 <a:srgbClr val="F1C232"/>
               </a:solidFill>

</xml_diff>